<commit_message>
feat: add table support, CJK fonts, corporate theme, and template analysis
- [P0] Add table functions: create_table, set_cell, merge_cells, set_table_style, create_table_slide
- [P0] Support CJK fonts (微软雅黑/等线) with configurable font_name parameter
- [P1] Add COLORS_CORPORATE light theme (white bg + blue header) for enterprise use
- [P1] Add analyze_template() to inspect existing PPTX structure
- [P1] Add Known Pitfalls section to agent.md (lxml cell content, merge order, etc.)
- [P2] Add add_section_label() for section divider bars
- [P2] Update default slide size to standard PowerPoint 16:9 (13.333 x 7.5 inches)
- Update agent.md workflow with environment check and template analysis steps
</commit_message>
<xml_diff>
--- a/scripts/example-presentation.pptx
+++ b/scripts/example-presentation.pptx
@@ -9,8 +9,9 @@
     <p:sldId id="257" r:id="rId8"/>
     <p:sldId id="258" r:id="rId9"/>
     <p:sldId id="259" r:id="rId10"/>
+    <p:sldId id="260" r:id="rId11"/>
   </p:sldIdLst>
-  <p:sldSz cx="9144000" cy="5143500" type="screen4x3"/>
+  <p:sldSz cx="12191695" cy="6858000" type="screen4x3"/>
   <p:notesSz cx="6858000" cy="9144000"/>
   <p:defaultTextStyle>
     <a:defPPr>
@@ -3100,7 +3101,7 @@
         <p:spPr>
           <a:xfrm>
             <a:off x="0" y="0"/>
-            <a:ext cx="9144000" cy="5143500"/>
+            <a:ext cx="12191695" cy="6858000"/>
           </a:xfrm>
           <a:prstGeom prst="rect">
             <a:avLst/>
@@ -3143,7 +3144,7 @@
         <p:spPr>
           <a:xfrm>
             <a:off x="0" y="0"/>
-            <a:ext cx="9144000" cy="101600"/>
+            <a:ext cx="12191695" cy="101600"/>
           </a:xfrm>
           <a:prstGeom prst="rect">
             <a:avLst/>
@@ -3247,7 +3248,7 @@
                 <a:solidFill>
                   <a:srgbClr val="FFFFFF"/>
                 </a:solidFill>
-                <a:latin typeface="Arial"/>
+                <a:latin typeface="微软雅黑"/>
               </a:defRPr>
             </a:pPr>
             <a:r>
@@ -3283,7 +3284,7 @@
                 <a:solidFill>
                   <a:srgbClr val="667EEA"/>
                 </a:solidFill>
-                <a:latin typeface="Arial"/>
+                <a:latin typeface="微软雅黑"/>
               </a:defRPr>
             </a:pPr>
             <a:r>
@@ -3319,7 +3320,7 @@
                 <a:solidFill>
                   <a:srgbClr val="AAAAAA"/>
                 </a:solidFill>
-                <a:latin typeface="Arial"/>
+                <a:latin typeface="微软雅黑"/>
               </a:defRPr>
             </a:pPr>
             <a:r>
@@ -3355,7 +3356,7 @@
         <p:spPr>
           <a:xfrm>
             <a:off x="0" y="0"/>
-            <a:ext cx="9144000" cy="5143500"/>
+            <a:ext cx="12191695" cy="6858000"/>
           </a:xfrm>
           <a:prstGeom prst="rect">
             <a:avLst/>
@@ -3398,7 +3399,7 @@
         <p:spPr>
           <a:xfrm>
             <a:off x="0" y="0"/>
-            <a:ext cx="9144000" cy="731520"/>
+            <a:ext cx="12191695" cy="731520"/>
           </a:xfrm>
           <a:prstGeom prst="rect">
             <a:avLst/>
@@ -3459,7 +3460,7 @@
                 <a:solidFill>
                   <a:srgbClr val="FFFFFF"/>
                 </a:solidFill>
-                <a:latin typeface="Arial"/>
+                <a:latin typeface="微软雅黑"/>
               </a:defRPr>
             </a:pPr>
             <a:r>
@@ -3581,7 +3582,7 @@
                 <a:solidFill>
                   <a:srgbClr val="00D9FF"/>
                 </a:solidFill>
-                <a:latin typeface="Arial"/>
+                <a:latin typeface="微软雅黑"/>
               </a:rPr>
               <a:t>第一点</a:t>
             </a:r>
@@ -3590,7 +3591,7 @@
                 <a:solidFill>
                   <a:srgbClr val="FFFFFF"/>
                 </a:solidFill>
-                <a:latin typeface="Arial"/>
+                <a:latin typeface="微软雅黑"/>
               </a:rPr>
               <a:t> - 这是第一个要点的详细说明</a:t>
             </a:r>
@@ -3710,7 +3711,7 @@
                 <a:solidFill>
                   <a:srgbClr val="00D9FF"/>
                 </a:solidFill>
-                <a:latin typeface="Arial"/>
+                <a:latin typeface="微软雅黑"/>
               </a:rPr>
               <a:t>第二点</a:t>
             </a:r>
@@ -3719,7 +3720,7 @@
                 <a:solidFill>
                   <a:srgbClr val="FFFFFF"/>
                 </a:solidFill>
-                <a:latin typeface="Arial"/>
+                <a:latin typeface="微软雅黑"/>
               </a:rPr>
               <a:t> - 这是第二个要点的详细说明</a:t>
             </a:r>
@@ -3839,7 +3840,7 @@
                 <a:solidFill>
                   <a:srgbClr val="00D9FF"/>
                 </a:solidFill>
-                <a:latin typeface="Arial"/>
+                <a:latin typeface="微软雅黑"/>
               </a:rPr>
               <a:t>第三点</a:t>
             </a:r>
@@ -3848,7 +3849,7 @@
                 <a:solidFill>
                   <a:srgbClr val="FFFFFF"/>
                 </a:solidFill>
-                <a:latin typeface="Arial"/>
+                <a:latin typeface="微软雅黑"/>
               </a:rPr>
               <a:t> - 这是第三个要点的详细说明</a:t>
             </a:r>
@@ -3968,7 +3969,7 @@
                 <a:solidFill>
                   <a:srgbClr val="00D9FF"/>
                 </a:solidFill>
-                <a:latin typeface="Arial"/>
+                <a:latin typeface="微软雅黑"/>
               </a:rPr>
               <a:t>第四点</a:t>
             </a:r>
@@ -3977,7 +3978,7 @@
                 <a:solidFill>
                   <a:srgbClr val="FFFFFF"/>
                 </a:solidFill>
-                <a:latin typeface="Arial"/>
+                <a:latin typeface="微软雅黑"/>
               </a:rPr>
               <a:t> - 这是第四个要点的详细说明</a:t>
             </a:r>
@@ -4011,7 +4012,7 @@
         <p:spPr>
           <a:xfrm>
             <a:off x="0" y="0"/>
-            <a:ext cx="9144000" cy="5143500"/>
+            <a:ext cx="12191695" cy="6858000"/>
           </a:xfrm>
           <a:prstGeom prst="rect">
             <a:avLst/>
@@ -4054,7 +4055,7 @@
         <p:spPr>
           <a:xfrm>
             <a:off x="0" y="0"/>
-            <a:ext cx="9144000" cy="731520"/>
+            <a:ext cx="12191695" cy="731520"/>
           </a:xfrm>
           <a:prstGeom prst="rect">
             <a:avLst/>
@@ -4115,7 +4116,7 @@
                 <a:solidFill>
                   <a:srgbClr val="FFFFFF"/>
                 </a:solidFill>
-                <a:latin typeface="Arial"/>
+                <a:latin typeface="微软雅黑"/>
               </a:defRPr>
             </a:pPr>
             <a:r>
@@ -4237,7 +4238,7 @@
                 <a:solidFill>
                   <a:srgbClr val="FFFFFF"/>
                 </a:solidFill>
-                <a:latin typeface="Arial"/>
+                <a:latin typeface="微软雅黑"/>
               </a:defRPr>
             </a:pPr>
             <a:r>
@@ -4273,7 +4274,7 @@
                 <a:solidFill>
                   <a:srgbClr val="AAAAAA"/>
                 </a:solidFill>
-                <a:latin typeface="Arial"/>
+                <a:latin typeface="微软雅黑"/>
               </a:defRPr>
             </a:pPr>
             <a:r>
@@ -4395,7 +4396,7 @@
                 <a:solidFill>
                   <a:srgbClr val="FFFFFF"/>
                 </a:solidFill>
-                <a:latin typeface="Arial"/>
+                <a:latin typeface="微软雅黑"/>
               </a:defRPr>
             </a:pPr>
             <a:r>
@@ -4431,7 +4432,7 @@
                 <a:solidFill>
                   <a:srgbClr val="AAAAAA"/>
                 </a:solidFill>
-                <a:latin typeface="Arial"/>
+                <a:latin typeface="微软雅黑"/>
               </a:defRPr>
             </a:pPr>
             <a:r>
@@ -4553,7 +4554,7 @@
                 <a:solidFill>
                   <a:srgbClr val="FFFFFF"/>
                 </a:solidFill>
-                <a:latin typeface="Arial"/>
+                <a:latin typeface="微软雅黑"/>
               </a:defRPr>
             </a:pPr>
             <a:r>
@@ -4589,7 +4590,7 @@
                 <a:solidFill>
                   <a:srgbClr val="AAAAAA"/>
                 </a:solidFill>
-                <a:latin typeface="Arial"/>
+                <a:latin typeface="微软雅黑"/>
               </a:defRPr>
             </a:pPr>
             <a:r>
@@ -4711,7 +4712,7 @@
                 <a:solidFill>
                   <a:srgbClr val="FFFFFF"/>
                 </a:solidFill>
-                <a:latin typeface="Arial"/>
+                <a:latin typeface="微软雅黑"/>
               </a:defRPr>
             </a:pPr>
             <a:r>
@@ -4747,7 +4748,7 @@
                 <a:solidFill>
                   <a:srgbClr val="AAAAAA"/>
                 </a:solidFill>
-                <a:latin typeface="Arial"/>
+                <a:latin typeface="微软雅黑"/>
               </a:defRPr>
             </a:pPr>
             <a:r>
@@ -4869,7 +4870,7 @@
                 <a:solidFill>
                   <a:srgbClr val="FFFFFF"/>
                 </a:solidFill>
-                <a:latin typeface="Arial"/>
+                <a:latin typeface="微软雅黑"/>
               </a:defRPr>
             </a:pPr>
             <a:r>
@@ -4905,7 +4906,7 @@
                 <a:solidFill>
                   <a:srgbClr val="AAAAAA"/>
                 </a:solidFill>
-                <a:latin typeface="Arial"/>
+                <a:latin typeface="微软雅黑"/>
               </a:defRPr>
             </a:pPr>
             <a:r>
@@ -5027,7 +5028,7 @@
                 <a:solidFill>
                   <a:srgbClr val="FFFFFF"/>
                 </a:solidFill>
-                <a:latin typeface="Arial"/>
+                <a:latin typeface="微软雅黑"/>
               </a:defRPr>
             </a:pPr>
             <a:r>
@@ -5063,7 +5064,7 @@
                 <a:solidFill>
                   <a:srgbClr val="AAAAAA"/>
                 </a:solidFill>
-                <a:latin typeface="Arial"/>
+                <a:latin typeface="微软雅黑"/>
               </a:defRPr>
             </a:pPr>
             <a:r>
@@ -5099,7 +5100,7 @@
         <p:spPr>
           <a:xfrm>
             <a:off x="0" y="0"/>
-            <a:ext cx="9144000" cy="5143500"/>
+            <a:ext cx="12191695" cy="6858000"/>
           </a:xfrm>
           <a:prstGeom prst="rect">
             <a:avLst/>
@@ -5142,7 +5143,7 @@
         <p:spPr>
           <a:xfrm>
             <a:off x="0" y="0"/>
-            <a:ext cx="9144000" cy="731520"/>
+            <a:ext cx="12191695" cy="731520"/>
           </a:xfrm>
           <a:prstGeom prst="rect">
             <a:avLst/>
@@ -5203,7 +5204,503 @@
                 <a:solidFill>
                   <a:srgbClr val="FFFFFF"/>
                 </a:solidFill>
-                <a:latin typeface="Arial"/>
+                <a:latin typeface="微软雅黑"/>
+              </a:defRPr>
+            </a:pPr>
+            <a:r>
+              <a:t>数据概览</a:t>
+            </a:r>
+          </a:p>
+        </p:txBody>
+      </p:sp>
+      <p:graphicFrame>
+        <p:nvGraphicFramePr>
+          <p:cNvPr id="5" name="Table 4"/>
+          <p:cNvGraphicFramePr>
+            <a:graphicFrameLocks noGrp="1"/>
+          </p:cNvGraphicFramePr>
+          <p:nvPr/>
+        </p:nvGraphicFramePr>
+        <p:xfrm>
+          <a:off x="457200" y="1005840"/>
+          <a:ext cx="11277295" cy="5486400"/>
+        </p:xfrm>
+        <a:graphic>
+          <a:graphicData uri="http://schemas.openxmlformats.org/drawingml/2006/table">
+            <a:tbl>
+              <a:tblPr firstRow="1" bandRow="1" firstCol="0">
+                <a:tableStyleId>{5C22544A-7EE6-4342-B048-85BDC9FD1C3A}</a:tableStyleId>
+              </a:tblPr>
+              <a:tblGrid>
+                <a:gridCol w="2819323"/>
+                <a:gridCol w="2819323"/>
+                <a:gridCol w="2819323"/>
+                <a:gridCol w="2819326"/>
+              </a:tblGrid>
+              <a:tr h="1371600">
+                <a:tc>
+                  <a:txBody>
+                    <a:bodyPr wrap="square"/>
+                    <a:lstStyle/>
+                    <a:p>
+                      <a:pPr algn="ctr"/>
+                      <a:r>
+                        <a:rPr sz="1100" b="1">
+                          <a:solidFill>
+                            <a:srgbClr val="FFFFFF"/>
+                          </a:solidFill>
+                          <a:latin typeface="微软雅黑"/>
+                        </a:rPr>
+                        <a:t>项目</a:t>
+                      </a:r>
+                    </a:p>
+                  </a:txBody>
+                  <a:tcPr anchor="ctr">
+                    <a:solidFill>
+                      <a:srgbClr val="667EEA"/>
+                    </a:solidFill>
+                  </a:tcPr>
+                </a:tc>
+                <a:tc>
+                  <a:txBody>
+                    <a:bodyPr wrap="square"/>
+                    <a:lstStyle/>
+                    <a:p>
+                      <a:pPr algn="ctr"/>
+                      <a:r>
+                        <a:rPr sz="1100" b="1">
+                          <a:solidFill>
+                            <a:srgbClr val="FFFFFF"/>
+                          </a:solidFill>
+                          <a:latin typeface="微软雅黑"/>
+                        </a:rPr>
+                        <a:t>状态</a:t>
+                      </a:r>
+                    </a:p>
+                  </a:txBody>
+                  <a:tcPr anchor="ctr">
+                    <a:solidFill>
+                      <a:srgbClr val="667EEA"/>
+                    </a:solidFill>
+                  </a:tcPr>
+                </a:tc>
+                <a:tc>
+                  <a:txBody>
+                    <a:bodyPr wrap="square"/>
+                    <a:lstStyle/>
+                    <a:p>
+                      <a:pPr algn="ctr"/>
+                      <a:r>
+                        <a:rPr sz="1100" b="1">
+                          <a:solidFill>
+                            <a:srgbClr val="FFFFFF"/>
+                          </a:solidFill>
+                          <a:latin typeface="微软雅黑"/>
+                        </a:rPr>
+                        <a:t>负责人</a:t>
+                      </a:r>
+                    </a:p>
+                  </a:txBody>
+                  <a:tcPr anchor="ctr">
+                    <a:solidFill>
+                      <a:srgbClr val="667EEA"/>
+                    </a:solidFill>
+                  </a:tcPr>
+                </a:tc>
+                <a:tc>
+                  <a:txBody>
+                    <a:bodyPr wrap="square"/>
+                    <a:lstStyle/>
+                    <a:p>
+                      <a:pPr algn="ctr"/>
+                      <a:r>
+                        <a:rPr sz="1100" b="1">
+                          <a:solidFill>
+                            <a:srgbClr val="FFFFFF"/>
+                          </a:solidFill>
+                          <a:latin typeface="微软雅黑"/>
+                        </a:rPr>
+                        <a:t>备注</a:t>
+                      </a:r>
+                    </a:p>
+                  </a:txBody>
+                  <a:tcPr anchor="ctr">
+                    <a:solidFill>
+                      <a:srgbClr val="667EEA"/>
+                    </a:solidFill>
+                  </a:tcPr>
+                </a:tc>
+              </a:tr>
+              <a:tr h="1371600">
+                <a:tc>
+                  <a:txBody>
+                    <a:bodyPr wrap="square"/>
+                    <a:lstStyle/>
+                    <a:p>
+                      <a:pPr algn="l"/>
+                      <a:r>
+                        <a:rPr sz="1000" b="0">
+                          <a:solidFill>
+                            <a:srgbClr val="000000"/>
+                          </a:solidFill>
+                          <a:latin typeface="微软雅黑"/>
+                        </a:rPr>
+                        <a:t>任务一</a:t>
+                      </a:r>
+                    </a:p>
+                  </a:txBody>
+                  <a:tcPr anchor="t"/>
+                </a:tc>
+                <a:tc>
+                  <a:txBody>
+                    <a:bodyPr wrap="square"/>
+                    <a:lstStyle/>
+                    <a:p>
+                      <a:pPr algn="l"/>
+                      <a:r>
+                        <a:rPr sz="1000" b="0">
+                          <a:solidFill>
+                            <a:srgbClr val="000000"/>
+                          </a:solidFill>
+                          <a:latin typeface="微软雅黑"/>
+                        </a:rPr>
+                        <a:t>已完成</a:t>
+                      </a:r>
+                    </a:p>
+                  </a:txBody>
+                  <a:tcPr anchor="t"/>
+                </a:tc>
+                <a:tc>
+                  <a:txBody>
+                    <a:bodyPr wrap="square"/>
+                    <a:lstStyle/>
+                    <a:p>
+                      <a:pPr algn="l"/>
+                      <a:r>
+                        <a:rPr sz="1000" b="0">
+                          <a:solidFill>
+                            <a:srgbClr val="000000"/>
+                          </a:solidFill>
+                          <a:latin typeface="微软雅黑"/>
+                        </a:rPr>
+                        <a:t>张三</a:t>
+                      </a:r>
+                    </a:p>
+                  </a:txBody>
+                  <a:tcPr anchor="t"/>
+                </a:tc>
+                <a:tc>
+                  <a:txBody>
+                    <a:bodyPr wrap="square"/>
+                    <a:lstStyle/>
+                    <a:p>
+                      <a:pPr algn="l"/>
+                      <a:r>
+                        <a:rPr sz="1000" b="0">
+                          <a:solidFill>
+                            <a:srgbClr val="000000"/>
+                          </a:solidFill>
+                          <a:latin typeface="微软雅黑"/>
+                        </a:rPr>
+                        <a:t>按时交付</a:t>
+                      </a:r>
+                    </a:p>
+                  </a:txBody>
+                  <a:tcPr anchor="t"/>
+                </a:tc>
+              </a:tr>
+              <a:tr h="1371600">
+                <a:tc>
+                  <a:txBody>
+                    <a:bodyPr wrap="square"/>
+                    <a:lstStyle/>
+                    <a:p>
+                      <a:pPr algn="l"/>
+                      <a:r>
+                        <a:rPr sz="1000" b="0">
+                          <a:solidFill>
+                            <a:srgbClr val="000000"/>
+                          </a:solidFill>
+                          <a:latin typeface="微软雅黑"/>
+                        </a:rPr>
+                        <a:t>任务二</a:t>
+                      </a:r>
+                    </a:p>
+                  </a:txBody>
+                  <a:tcPr anchor="t"/>
+                </a:tc>
+                <a:tc>
+                  <a:txBody>
+                    <a:bodyPr wrap="square"/>
+                    <a:lstStyle/>
+                    <a:p>
+                      <a:pPr algn="l"/>
+                      <a:r>
+                        <a:rPr sz="1000" b="0">
+                          <a:solidFill>
+                            <a:srgbClr val="000000"/>
+                          </a:solidFill>
+                          <a:latin typeface="微软雅黑"/>
+                        </a:rPr>
+                        <a:t>进行中</a:t>
+                      </a:r>
+                    </a:p>
+                  </a:txBody>
+                  <a:tcPr anchor="t"/>
+                </a:tc>
+                <a:tc>
+                  <a:txBody>
+                    <a:bodyPr wrap="square"/>
+                    <a:lstStyle/>
+                    <a:p>
+                      <a:pPr algn="l"/>
+                      <a:r>
+                        <a:rPr sz="1000" b="0">
+                          <a:solidFill>
+                            <a:srgbClr val="000000"/>
+                          </a:solidFill>
+                          <a:latin typeface="微软雅黑"/>
+                        </a:rPr>
+                        <a:t>李四</a:t>
+                      </a:r>
+                    </a:p>
+                  </a:txBody>
+                  <a:tcPr anchor="t"/>
+                </a:tc>
+                <a:tc>
+                  <a:txBody>
+                    <a:bodyPr wrap="square"/>
+                    <a:lstStyle/>
+                    <a:p>
+                      <a:pPr algn="l"/>
+                      <a:r>
+                        <a:rPr sz="1000" b="0">
+                          <a:solidFill>
+                            <a:srgbClr val="000000"/>
+                          </a:solidFill>
+                          <a:latin typeface="微软雅黑"/>
+                        </a:rPr>
+                        <a:t>需要协调</a:t>
+                      </a:r>
+                    </a:p>
+                  </a:txBody>
+                  <a:tcPr anchor="t"/>
+                </a:tc>
+              </a:tr>
+              <a:tr h="1371600">
+                <a:tc>
+                  <a:txBody>
+                    <a:bodyPr wrap="square"/>
+                    <a:lstStyle/>
+                    <a:p>
+                      <a:pPr algn="l"/>
+                      <a:r>
+                        <a:rPr sz="1000" b="0">
+                          <a:solidFill>
+                            <a:srgbClr val="000000"/>
+                          </a:solidFill>
+                          <a:latin typeface="微软雅黑"/>
+                        </a:rPr>
+                        <a:t>任务三</a:t>
+                      </a:r>
+                    </a:p>
+                  </a:txBody>
+                  <a:tcPr anchor="t"/>
+                </a:tc>
+                <a:tc>
+                  <a:txBody>
+                    <a:bodyPr wrap="square"/>
+                    <a:lstStyle/>
+                    <a:p>
+                      <a:pPr algn="l"/>
+                      <a:r>
+                        <a:rPr sz="1000" b="0">
+                          <a:solidFill>
+                            <a:srgbClr val="000000"/>
+                          </a:solidFill>
+                          <a:latin typeface="微软雅黑"/>
+                        </a:rPr>
+                        <a:t>未开始</a:t>
+                      </a:r>
+                    </a:p>
+                  </a:txBody>
+                  <a:tcPr anchor="t"/>
+                </a:tc>
+                <a:tc>
+                  <a:txBody>
+                    <a:bodyPr wrap="square"/>
+                    <a:lstStyle/>
+                    <a:p>
+                      <a:pPr algn="l"/>
+                      <a:r>
+                        <a:rPr sz="1000" b="0">
+                          <a:solidFill>
+                            <a:srgbClr val="000000"/>
+                          </a:solidFill>
+                          <a:latin typeface="微软雅黑"/>
+                        </a:rPr>
+                        <a:t>王五</a:t>
+                      </a:r>
+                    </a:p>
+                  </a:txBody>
+                  <a:tcPr anchor="t"/>
+                </a:tc>
+                <a:tc>
+                  <a:txBody>
+                    <a:bodyPr wrap="square"/>
+                    <a:lstStyle/>
+                    <a:p>
+                      <a:pPr algn="l"/>
+                      <a:r>
+                        <a:rPr sz="1000" b="0">
+                          <a:solidFill>
+                            <a:srgbClr val="000000"/>
+                          </a:solidFill>
+                          <a:latin typeface="微软雅黑"/>
+                        </a:rPr>
+                        <a:t>待排期</a:t>
+                      </a:r>
+                    </a:p>
+                  </a:txBody>
+                  <a:tcPr anchor="t"/>
+                </a:tc>
+              </a:tr>
+            </a:tbl>
+          </a:graphicData>
+        </a:graphic>
+      </p:graphicFrame>
+    </p:spTree>
+  </p:cSld>
+  <p:clrMapOvr>
+    <a:masterClrMapping/>
+  </p:clrMapOvr>
+</p:sld>
+</file>
+
+<file path=ppt/slides/slide5.xml><?xml version="1.0" encoding="utf-8"?>
+<p:sld xmlns:a="http://schemas.openxmlformats.org/drawingml/2006/main" xmlns:p="http://schemas.openxmlformats.org/presentationml/2006/main" xmlns:r="http://schemas.openxmlformats.org/officeDocument/2006/relationships">
+  <p:cSld>
+    <p:spTree>
+      <p:nvGrpSpPr>
+        <p:cNvPr id="1" name=""/>
+        <p:cNvGrpSpPr/>
+        <p:nvPr/>
+      </p:nvGrpSpPr>
+      <p:grpSpPr/>
+      <p:sp>
+        <p:nvSpPr>
+          <p:cNvPr id="2" name="Rectangle 1"/>
+          <p:cNvSpPr/>
+          <p:nvPr/>
+        </p:nvSpPr>
+        <p:spPr>
+          <a:xfrm>
+            <a:off x="0" y="0"/>
+            <a:ext cx="12191695" cy="6858000"/>
+          </a:xfrm>
+          <a:prstGeom prst="rect">
+            <a:avLst/>
+          </a:prstGeom>
+          <a:solidFill>
+            <a:srgbClr val="0F0F23"/>
+          </a:solidFill>
+          <a:ln>
+            <a:noFill/>
+          </a:ln>
+        </p:spPr>
+        <p:style>
+          <a:lnRef idx="1">
+            <a:schemeClr val="accent1"/>
+          </a:lnRef>
+          <a:fillRef idx="3">
+            <a:schemeClr val="accent1"/>
+          </a:fillRef>
+          <a:effectRef idx="2">
+            <a:schemeClr val="accent1"/>
+          </a:effectRef>
+          <a:fontRef idx="minor">
+            <a:schemeClr val="lt1"/>
+          </a:fontRef>
+        </p:style>
+        <p:txBody>
+          <a:bodyPr rtlCol="0" anchor="ctr"/>
+          <a:lstStyle/>
+          <a:p>
+            <a:pPr algn="ctr"/>
+          </a:p>
+        </p:txBody>
+      </p:sp>
+      <p:sp>
+        <p:nvSpPr>
+          <p:cNvPr id="3" name="Rectangle 2"/>
+          <p:cNvSpPr/>
+          <p:nvPr/>
+        </p:nvSpPr>
+        <p:spPr>
+          <a:xfrm>
+            <a:off x="0" y="0"/>
+            <a:ext cx="12191695" cy="731520"/>
+          </a:xfrm>
+          <a:prstGeom prst="rect">
+            <a:avLst/>
+          </a:prstGeom>
+          <a:solidFill>
+            <a:srgbClr val="667EEA"/>
+          </a:solidFill>
+          <a:ln>
+            <a:noFill/>
+          </a:ln>
+        </p:spPr>
+        <p:style>
+          <a:lnRef idx="1">
+            <a:schemeClr val="accent1"/>
+          </a:lnRef>
+          <a:fillRef idx="3">
+            <a:schemeClr val="accent1"/>
+          </a:fillRef>
+          <a:effectRef idx="2">
+            <a:schemeClr val="accent1"/>
+          </a:effectRef>
+          <a:fontRef idx="minor">
+            <a:schemeClr val="lt1"/>
+          </a:fontRef>
+        </p:style>
+        <p:txBody>
+          <a:bodyPr rtlCol="0" anchor="ctr"/>
+          <a:lstStyle/>
+          <a:p>
+            <a:pPr algn="ctr"/>
+          </a:p>
+        </p:txBody>
+      </p:sp>
+      <p:sp>
+        <p:nvSpPr>
+          <p:cNvPr id="4" name="TextBox 3"/>
+          <p:cNvSpPr txBox="1"/>
+          <p:nvPr/>
+        </p:nvSpPr>
+        <p:spPr>
+          <a:xfrm>
+            <a:off x="457200" y="164592"/>
+            <a:ext cx="8229600" cy="457200"/>
+          </a:xfrm>
+          <a:prstGeom prst="rect">
+            <a:avLst/>
+          </a:prstGeom>
+          <a:noFill/>
+        </p:spPr>
+        <p:txBody>
+          <a:bodyPr wrap="square">
+            <a:spAutoFit/>
+          </a:bodyPr>
+          <a:lstStyle/>
+          <a:p>
+            <a:pPr algn="l">
+              <a:defRPr sz="2800" b="1">
+                <a:solidFill>
+                  <a:srgbClr val="FFFFFF"/>
+                </a:solidFill>
+                <a:latin typeface="微软雅黑"/>
               </a:defRPr>
             </a:pPr>
             <a:r>
@@ -5282,7 +5779,7 @@
                 <a:solidFill>
                   <a:srgbClr val="FFFFFF"/>
                 </a:solidFill>
-                <a:latin typeface="Arial"/>
+                <a:latin typeface="微软雅黑"/>
               </a:defRPr>
             </a:pPr>
             <a:r>

</xml_diff>